<commit_message>
Update README and deck with Exasol benchmark results
</commit_message>
<xml_diff>
--- a/DeclineLens_Pitch_Deck.pptx
+++ b/DeclineLens_Pitch_Deck.pptx
@@ -4196,7 +4196,7 @@
                 <a:ea typeface="Cambria" pitchFamily="34" charset="-122"/>
                 <a:cs typeface="Cambria" pitchFamily="34" charset="-120"/>
               </a:rPr>
-              <a:t>69M</a:t>
+              <a:t>9.9s</a:t>
             </a:r>
             <a:endParaRPr lang="en-US" sz="5600" dirty="0"/>
           </a:p>
@@ -4232,7 +4232,7 @@
                   <a:srgbClr val="FFFFFF"/>
                 </a:solidFill>
               </a:rPr>
-              <a:t>what-ifs in the largest benchmark run</a:t>
+              <a:t>to score 69M what-ifs on Exasol Personal (1M applicants)</a:t>
             </a:r>
             <a:endParaRPr lang="en-US" sz="1500" dirty="0"/>
           </a:p>
@@ -4268,7 +4268,7 @@
                   <a:srgbClr val="CFCDE6"/>
                 </a:solidFill>
               </a:rPr>
-              <a:t>SQL scores equal an independent Python version, and the cheapest plan the database returns matches an exhaustive search. Benchmark figures are from the local stand-in; regenerate on Exasol with the bench command.</a:t>
+              <a:t>SQL scores equal an independent Python version, and the cheapest plan the database returns matches an exhaustive search. Benchmark measured on Exasol Personal running locally in Podman on a Windows laptop.</a:t>
             </a:r>
             <a:endParaRPr lang="en-US" sz="1300" dirty="0"/>
           </a:p>

</xml_diff>